<commit_message>
updating tables and figures
</commit_message>
<xml_diff>
--- a/tables_figs/methods-diagram.pptx
+++ b/tables_figs/methods-diagram.pptx
@@ -260,7 +260,7 @@
           <a:p>
             <a:fld id="{31A3BF5B-804A-F348-88E3-0396B5062129}" type="datetimeFigureOut">
               <a:rPr lang="en-US" smtClean="0"/>
-              <a:t>2/24/26</a:t>
+              <a:t>9/4/26</a:t>
             </a:fld>
             <a:endParaRPr lang="en-US"/>
           </a:p>
@@ -458,7 +458,7 @@
           <a:p>
             <a:fld id="{31A3BF5B-804A-F348-88E3-0396B5062129}" type="datetimeFigureOut">
               <a:rPr lang="en-US" smtClean="0"/>
-              <a:t>2/24/26</a:t>
+              <a:t>9/4/26</a:t>
             </a:fld>
             <a:endParaRPr lang="en-US"/>
           </a:p>
@@ -666,7 +666,7 @@
           <a:p>
             <a:fld id="{31A3BF5B-804A-F348-88E3-0396B5062129}" type="datetimeFigureOut">
               <a:rPr lang="en-US" smtClean="0"/>
-              <a:t>2/24/26</a:t>
+              <a:t>9/4/26</a:t>
             </a:fld>
             <a:endParaRPr lang="en-US"/>
           </a:p>
@@ -864,7 +864,7 @@
           <a:p>
             <a:fld id="{31A3BF5B-804A-F348-88E3-0396B5062129}" type="datetimeFigureOut">
               <a:rPr lang="en-US" smtClean="0"/>
-              <a:t>2/24/26</a:t>
+              <a:t>9/4/26</a:t>
             </a:fld>
             <a:endParaRPr lang="en-US"/>
           </a:p>
@@ -1139,7 +1139,7 @@
           <a:p>
             <a:fld id="{31A3BF5B-804A-F348-88E3-0396B5062129}" type="datetimeFigureOut">
               <a:rPr lang="en-US" smtClean="0"/>
-              <a:t>2/24/26</a:t>
+              <a:t>9/4/26</a:t>
             </a:fld>
             <a:endParaRPr lang="en-US"/>
           </a:p>
@@ -1404,7 +1404,7 @@
           <a:p>
             <a:fld id="{31A3BF5B-804A-F348-88E3-0396B5062129}" type="datetimeFigureOut">
               <a:rPr lang="en-US" smtClean="0"/>
-              <a:t>2/24/26</a:t>
+              <a:t>9/4/26</a:t>
             </a:fld>
             <a:endParaRPr lang="en-US"/>
           </a:p>
@@ -1816,7 +1816,7 @@
           <a:p>
             <a:fld id="{31A3BF5B-804A-F348-88E3-0396B5062129}" type="datetimeFigureOut">
               <a:rPr lang="en-US" smtClean="0"/>
-              <a:t>2/24/26</a:t>
+              <a:t>9/4/26</a:t>
             </a:fld>
             <a:endParaRPr lang="en-US"/>
           </a:p>
@@ -1957,7 +1957,7 @@
           <a:p>
             <a:fld id="{31A3BF5B-804A-F348-88E3-0396B5062129}" type="datetimeFigureOut">
               <a:rPr lang="en-US" smtClean="0"/>
-              <a:t>2/24/26</a:t>
+              <a:t>9/4/26</a:t>
             </a:fld>
             <a:endParaRPr lang="en-US"/>
           </a:p>
@@ -2070,7 +2070,7 @@
           <a:p>
             <a:fld id="{31A3BF5B-804A-F348-88E3-0396B5062129}" type="datetimeFigureOut">
               <a:rPr lang="en-US" smtClean="0"/>
-              <a:t>2/24/26</a:t>
+              <a:t>9/4/26</a:t>
             </a:fld>
             <a:endParaRPr lang="en-US"/>
           </a:p>
@@ -2381,7 +2381,7 @@
           <a:p>
             <a:fld id="{31A3BF5B-804A-F348-88E3-0396B5062129}" type="datetimeFigureOut">
               <a:rPr lang="en-US" smtClean="0"/>
-              <a:t>2/24/26</a:t>
+              <a:t>9/4/26</a:t>
             </a:fld>
             <a:endParaRPr lang="en-US"/>
           </a:p>
@@ -2669,7 +2669,7 @@
           <a:p>
             <a:fld id="{31A3BF5B-804A-F348-88E3-0396B5062129}" type="datetimeFigureOut">
               <a:rPr lang="en-US" smtClean="0"/>
-              <a:t>2/24/26</a:t>
+              <a:t>9/4/26</a:t>
             </a:fld>
             <a:endParaRPr lang="en-US"/>
           </a:p>
@@ -2910,7 +2910,7 @@
           <a:p>
             <a:fld id="{31A3BF5B-804A-F348-88E3-0396B5062129}" type="datetimeFigureOut">
               <a:rPr lang="en-US" smtClean="0"/>
-              <a:t>2/24/26</a:t>
+              <a:t>9/4/26</a:t>
             </a:fld>
             <a:endParaRPr lang="en-US"/>
           </a:p>
@@ -4674,7 +4674,7 @@
           <a:p>
             <a:r>
               <a:rPr lang="en-US" dirty="0"/>
-              <a:t>Drop 58 state-years without efficiency gap data</a:t>
+              <a:t>Drop 60 state-years without efficiency gap data</a:t>
             </a:r>
           </a:p>
         </p:txBody>
@@ -4814,7 +4814,7 @@
           <a:p>
             <a:r>
               <a:rPr lang="en-US" dirty="0"/>
-              <a:t>n = 638 state-years</a:t>
+              <a:t>n = 636 state-years</a:t>
             </a:r>
           </a:p>
         </p:txBody>

</xml_diff>